<commit_message>
Added example for Naive Bayes and an exercise
</commit_message>
<xml_diff>
--- a/01 - Intro Statistical Learning Theory.pptx
+++ b/01 - Intro Statistical Learning Theory.pptx
@@ -20,8 +20,7 @@
     <p:sldId id="284" r:id="rId17"/>
     <p:sldId id="285" r:id="rId18"/>
     <p:sldId id="286" r:id="rId19"/>
-    <p:sldId id="269" r:id="rId20"/>
-    <p:sldId id="258" r:id="rId21"/>
+    <p:sldId id="258" r:id="rId20"/>
   </p:sldIdLst>
   <p:sldSz cx="12192000" cy="6858000"/>
   <p:notesSz cx="6858000" cy="9144000"/>
@@ -372,7 +371,7 @@
           <a:p>
             <a:fld id="{9184DA70-C731-4C70-880D-CCD4705E623C}" type="datetime1">
               <a:rPr lang="en-US" smtClean="0"/>
-              <a:t>6/28/2025</a:t>
+              <a:t>7/18/2025</a:t>
             </a:fld>
             <a:endParaRPr lang="en-US" dirty="0"/>
           </a:p>
@@ -560,7 +559,7 @@
           <a:p>
             <a:fld id="{B612A279-0833-481D-8C56-F67FD0AC6C50}" type="datetime1">
               <a:rPr lang="en-US" smtClean="0"/>
-              <a:t>6/28/2025</a:t>
+              <a:t>7/18/2025</a:t>
             </a:fld>
             <a:endParaRPr lang="en-US" dirty="0"/>
           </a:p>
@@ -802,7 +801,7 @@
           <a:p>
             <a:fld id="{6587DA83-5663-4C9C-B9AA-0B40A3DAFF81}" type="datetime1">
               <a:rPr lang="en-US" smtClean="0"/>
-              <a:t>6/28/2025</a:t>
+              <a:t>7/18/2025</a:t>
             </a:fld>
             <a:endParaRPr lang="en-US" dirty="0"/>
           </a:p>
@@ -990,7 +989,7 @@
           <a:p>
             <a:fld id="{4BE1D723-8F53-4F53-90B0-1982A396982E}" type="datetime1">
               <a:rPr lang="en-US" smtClean="0"/>
-              <a:t>6/28/2025</a:t>
+              <a:t>7/18/2025</a:t>
             </a:fld>
             <a:endParaRPr lang="en-US" dirty="0"/>
           </a:p>
@@ -1363,7 +1362,7 @@
           <a:p>
             <a:fld id="{97669AF7-7BEB-44E4-9852-375E34362B5B}" type="datetime1">
               <a:rPr lang="en-US" smtClean="0"/>
-              <a:t>6/28/2025</a:t>
+              <a:t>7/18/2025</a:t>
             </a:fld>
             <a:endParaRPr lang="en-US" dirty="0"/>
           </a:p>
@@ -1618,7 +1617,7 @@
           <a:p>
             <a:fld id="{BAAAC38D-0552-4C82-B593-E6124DFADBE2}" type="datetime1">
               <a:rPr lang="en-US" smtClean="0"/>
-              <a:t>6/28/2025</a:t>
+              <a:t>7/18/2025</a:t>
             </a:fld>
             <a:endParaRPr lang="en-US" dirty="0"/>
           </a:p>
@@ -2015,7 +2014,7 @@
           <a:p>
             <a:fld id="{D9DF0F1C-5577-4ACB-BB62-DF8F3C494C7E}" type="datetime1">
               <a:rPr lang="en-US" smtClean="0"/>
-              <a:t>6/28/2025</a:t>
+              <a:t>7/18/2025</a:t>
             </a:fld>
             <a:endParaRPr lang="en-US" dirty="0"/>
           </a:p>
@@ -2151,7 +2150,7 @@
           <a:p>
             <a:fld id="{1775B394-D9F9-4F0C-B15D-605F45CB9E9F}" type="datetime1">
               <a:rPr lang="en-US" smtClean="0"/>
-              <a:t>6/28/2025</a:t>
+              <a:t>7/18/2025</a:t>
             </a:fld>
             <a:endParaRPr lang="en-US" dirty="0"/>
           </a:p>
@@ -2308,7 +2307,7 @@
           <a:p>
             <a:fld id="{39667345-2558-425A-8533-9BFDBCE15005}" type="datetime1">
               <a:rPr lang="en-US" smtClean="0"/>
-              <a:t>6/28/2025</a:t>
+              <a:t>7/18/2025</a:t>
             </a:fld>
             <a:endParaRPr lang="en-US" dirty="0"/>
           </a:p>
@@ -2637,7 +2636,7 @@
           <a:p>
             <a:fld id="{92BEA474-078D-4E9B-9B14-09A87B19DC46}" type="datetime1">
               <a:rPr lang="en-US" smtClean="0"/>
-              <a:t>6/28/2025</a:t>
+              <a:t>7/18/2025</a:t>
             </a:fld>
             <a:endParaRPr lang="en-US" dirty="0"/>
           </a:p>
@@ -2987,7 +2986,7 @@
           <a:p>
             <a:fld id="{4907D986-8816-4272-A432-0437A28A9828}" type="datetime1">
               <a:rPr lang="en-US" smtClean="0"/>
-              <a:t>6/28/2025</a:t>
+              <a:t>7/18/2025</a:t>
             </a:fld>
             <a:endParaRPr lang="en-US" dirty="0"/>
           </a:p>
@@ -3248,7 +3247,7 @@
           <a:p>
             <a:fld id="{62D6E202-B606-4609-B914-27C9371A1F6D}" type="datetime1">
               <a:rPr lang="en-US" smtClean="0"/>
-              <a:t>6/28/2025</a:t>
+              <a:t>7/18/2025</a:t>
             </a:fld>
             <a:endParaRPr lang="en-US" dirty="0"/>
           </a:p>
@@ -4954,114 +4953,6 @@
 <file path=ppt/slides/slide16.xml><?xml version="1.0" encoding="utf-8"?>
 <p:sld xmlns:a="http://schemas.openxmlformats.org/drawingml/2006/main" xmlns:r="http://schemas.openxmlformats.org/officeDocument/2006/relationships" xmlns:p="http://schemas.openxmlformats.org/presentationml/2006/main">
   <p:cSld>
-    <p:spTree>
-      <p:nvGrpSpPr>
-        <p:cNvPr id="1" name=""/>
-        <p:cNvGrpSpPr/>
-        <p:nvPr/>
-      </p:nvGrpSpPr>
-      <p:grpSpPr>
-        <a:xfrm>
-          <a:off x="0" y="0"/>
-          <a:ext cx="0" cy="0"/>
-          <a:chOff x="0" y="0"/>
-          <a:chExt cx="0" cy="0"/>
-        </a:xfrm>
-      </p:grpSpPr>
-      <p:sp>
-        <p:nvSpPr>
-          <p:cNvPr id="2" name="Title 1">
-            <a:extLst>
-              <a:ext uri="{FF2B5EF4-FFF2-40B4-BE49-F238E27FC236}">
-                <a16:creationId xmlns:a16="http://schemas.microsoft.com/office/drawing/2014/main" id="{9AB2EA78-AEB3-469B-9025-3B17201A457B}"/>
-              </a:ext>
-            </a:extLst>
-          </p:cNvPr>
-          <p:cNvSpPr>
-            <a:spLocks noGrp="1"/>
-          </p:cNvSpPr>
-          <p:nvPr>
-            <p:ph type="ctrTitle"/>
-          </p:nvPr>
-        </p:nvSpPr>
-        <p:spPr>
-          <a:xfrm>
-            <a:off x="1097280" y="758952"/>
-            <a:ext cx="10058400" cy="3892168"/>
-          </a:xfrm>
-        </p:spPr>
-        <p:txBody>
-          <a:bodyPr anchor="ctr">
-            <a:normAutofit/>
-          </a:bodyPr>
-          <a:lstStyle/>
-          <a:p>
-            <a:pPr lvl="0" algn="ctr"/>
-            <a:r>
-              <a:rPr lang="en-US" sz="4800" i="1" dirty="0">
-                <a:solidFill>
-                  <a:srgbClr val="FFFFFF"/>
-                </a:solidFill>
-              </a:rPr>
-              <a:t>Q&amp;A</a:t>
-            </a:r>
-          </a:p>
-        </p:txBody>
-      </p:sp>
-      <p:sp>
-        <p:nvSpPr>
-          <p:cNvPr id="3" name="TextBox 2">
-            <a:extLst>
-              <a:ext uri="{FF2B5EF4-FFF2-40B4-BE49-F238E27FC236}">
-                <a16:creationId xmlns:a16="http://schemas.microsoft.com/office/drawing/2014/main" id="{A6909B29-9A07-B2ED-0E93-98F27879FC93}"/>
-              </a:ext>
-            </a:extLst>
-          </p:cNvPr>
-          <p:cNvSpPr txBox="1"/>
-          <p:nvPr/>
-        </p:nvSpPr>
-        <p:spPr>
-          <a:xfrm>
-            <a:off x="2983832" y="1963554"/>
-            <a:ext cx="5101389" cy="830997"/>
-          </a:xfrm>
-          <a:prstGeom prst="rect">
-            <a:avLst/>
-          </a:prstGeom>
-          <a:noFill/>
-        </p:spPr>
-        <p:txBody>
-          <a:bodyPr wrap="square" rtlCol="0">
-            <a:spAutoFit/>
-          </a:bodyPr>
-          <a:lstStyle/>
-          <a:p>
-            <a:pPr algn="ctr"/>
-            <a:r>
-              <a:rPr lang="en-IN" sz="4800" i="1" dirty="0">
-                <a:latin typeface="+mj-lt"/>
-              </a:rPr>
-              <a:t>Codes</a:t>
-            </a:r>
-          </a:p>
-        </p:txBody>
-      </p:sp>
-    </p:spTree>
-    <p:extLst>
-      <p:ext uri="{BB962C8B-B14F-4D97-AF65-F5344CB8AC3E}">
-        <p14:creationId xmlns:p14="http://schemas.microsoft.com/office/powerpoint/2010/main" val="2156410355"/>
-      </p:ext>
-    </p:extLst>
-  </p:cSld>
-  <p:clrMapOvr>
-    <a:masterClrMapping/>
-  </p:clrMapOvr>
-</p:sld>
-</file>
-
-<file path=ppt/slides/slide17.xml><?xml version="1.0" encoding="utf-8"?>
-<p:sld xmlns:a="http://schemas.openxmlformats.org/drawingml/2006/main" xmlns:r="http://schemas.openxmlformats.org/officeDocument/2006/relationships" xmlns:p="http://schemas.openxmlformats.org/presentationml/2006/main">
-  <p:cSld>
     <p:bg>
       <p:bgPr>
         <a:solidFill>
@@ -7128,6 +7019,15 @@
 </file>
 
 <file path=customXml/item1.xml><?xml version="1.0" encoding="utf-8"?>
+<?mso-contentType ?>
+<FormTemplates xmlns="http://schemas.microsoft.com/sharepoint/v3/contenttype/forms">
+  <Display>DocumentLibraryForm</Display>
+  <Edit>DocumentLibraryForm</Edit>
+  <New>DocumentLibraryForm</New>
+</FormTemplates>
+</file>
+
+<file path=customXml/item2.xml><?xml version="1.0" encoding="utf-8"?>
 <p:properties xmlns:p="http://schemas.microsoft.com/office/2006/metadata/properties" xmlns:xsi="http://www.w3.org/2001/XMLSchema-instance" xmlns:pc="http://schemas.microsoft.com/office/infopath/2007/PartnerControls">
   <documentManagement>
     <_ip_UnifiedCompliancePolicyUIAction xmlns="http://schemas.microsoft.com/sharepoint/v3" xsi:nil="true"/>
@@ -7145,15 +7045,6 @@
     <MediaServiceKeyPoints xmlns="71af3243-3dd4-4a8d-8c0d-dd76da1f02a5" xsi:nil="true"/>
   </documentManagement>
 </p:properties>
-</file>
-
-<file path=customXml/item2.xml><?xml version="1.0" encoding="utf-8"?>
-<?mso-contentType ?>
-<FormTemplates xmlns="http://schemas.microsoft.com/sharepoint/v3/contenttype/forms">
-  <Display>DocumentLibraryForm</Display>
-  <Edit>DocumentLibraryForm</Edit>
-  <New>DocumentLibraryForm</New>
-</FormTemplates>
 </file>
 
 <file path=customXml/item3.xml><?xml version="1.0" encoding="utf-8"?>
@@ -7463,6 +7354,14 @@
 </file>
 
 <file path=customXml/itemProps1.xml><?xml version="1.0" encoding="utf-8"?>
+<ds:datastoreItem xmlns:ds="http://schemas.openxmlformats.org/officeDocument/2006/customXml" ds:itemID="{19DAD249-BF80-48EF-9AFB-36A11BCDC2CE}">
+  <ds:schemaRefs>
+    <ds:schemaRef ds:uri="http://schemas.microsoft.com/sharepoint/v3/contenttype/forms"/>
+  </ds:schemaRefs>
+</ds:datastoreItem>
+</file>
+
+<file path=customXml/itemProps2.xml><?xml version="1.0" encoding="utf-8"?>
 <ds:datastoreItem xmlns:ds="http://schemas.openxmlformats.org/officeDocument/2006/customXml" ds:itemID="{6F4F4D41-822D-40F2-A7AC-E4E6CB36CA7A}">
   <ds:schemaRefs>
     <ds:schemaRef ds:uri="http://schemas.microsoft.com/office/2006/metadata/properties"/>
@@ -7470,14 +7369,6 @@
     <ds:schemaRef ds:uri="http://schemas.microsoft.com/sharepoint/v3"/>
     <ds:schemaRef ds:uri="71af3243-3dd4-4a8d-8c0d-dd76da1f02a5"/>
     <ds:schemaRef ds:uri="230e9df3-be65-4c73-a93b-d1236ebd677e"/>
-  </ds:schemaRefs>
-</ds:datastoreItem>
-</file>
-
-<file path=customXml/itemProps2.xml><?xml version="1.0" encoding="utf-8"?>
-<ds:datastoreItem xmlns:ds="http://schemas.openxmlformats.org/officeDocument/2006/customXml" ds:itemID="{19DAD249-BF80-48EF-9AFB-36A11BCDC2CE}">
-  <ds:schemaRefs>
-    <ds:schemaRef ds:uri="http://schemas.microsoft.com/sharepoint/v3/contenttype/forms"/>
   </ds:schemaRefs>
 </ds:datastoreItem>
 </file>

</xml_diff>